<commit_message>
Update Domain Analysis presentation
</commit_message>
<xml_diff>
--- a/site/static/slides/Domain-Analysis.pptx
+++ b/site/static/slides/Domain-Analysis.pptx
@@ -12,9 +12,11 @@
     <p:sldId id="260" r:id="rId6"/>
     <p:sldId id="261" r:id="rId7"/>
     <p:sldId id="262" r:id="rId8"/>
-    <p:sldId id="263" r:id="rId9"/>
-    <p:sldId id="265" r:id="rId10"/>
-    <p:sldId id="264" r:id="rId11"/>
+    <p:sldId id="266" r:id="rId9"/>
+    <p:sldId id="267" r:id="rId10"/>
+    <p:sldId id="263" r:id="rId11"/>
+    <p:sldId id="265" r:id="rId12"/>
+    <p:sldId id="264" r:id="rId13"/>
   </p:sldIdLst>
   <p:sldSz cx="12192000" cy="6858000"/>
   <p:notesSz cx="12192000" cy="6858000"/>
@@ -193,7 +195,7 @@
           <a:p>
             <a:fld id="{1D8BD707-D9CF-40AE-B4C6-C98DA3205C09}" type="datetimeFigureOut">
               <a:rPr lang="en-US"/>
-              <a:t>9/2/2025</a:t>
+              <a:t>9/3/2026</a:t>
             </a:fld>
             <a:endParaRPr lang="en-US"/>
           </a:p>
@@ -370,7 +372,7 @@
           <a:p>
             <a:fld id="{1D8BD707-D9CF-40AE-B4C6-C98DA3205C09}" type="datetimeFigureOut">
               <a:rPr lang="en-US"/>
-              <a:t>9/2/2025</a:t>
+              <a:t>9/3/2026</a:t>
             </a:fld>
             <a:endParaRPr lang="en-US"/>
           </a:p>
@@ -584,7 +586,7 @@
           <a:p>
             <a:fld id="{1D8BD707-D9CF-40AE-B4C6-C98DA3205C09}" type="datetimeFigureOut">
               <a:rPr lang="en-US"/>
-              <a:t>9/2/2025</a:t>
+              <a:t>9/3/2026</a:t>
             </a:fld>
             <a:endParaRPr lang="en-US"/>
           </a:p>
@@ -732,7 +734,7 @@
           <a:p>
             <a:fld id="{1D8BD707-D9CF-40AE-B4C6-C98DA3205C09}" type="datetimeFigureOut">
               <a:rPr lang="en-US"/>
-              <a:t>9/2/2025</a:t>
+              <a:t>9/3/2026</a:t>
             </a:fld>
             <a:endParaRPr lang="en-US"/>
           </a:p>
@@ -851,7 +853,7 @@
           <a:p>
             <a:fld id="{1D8BD707-D9CF-40AE-B4C6-C98DA3205C09}" type="datetimeFigureOut">
               <a:rPr lang="en-US"/>
-              <a:t>9/2/2025</a:t>
+              <a:t>9/3/2026</a:t>
             </a:fld>
             <a:endParaRPr lang="en-US"/>
           </a:p>
@@ -1076,7 +1078,7 @@
           <a:p>
             <a:fld id="{1D8BD707-D9CF-40AE-B4C6-C98DA3205C09}" type="datetimeFigureOut">
               <a:rPr lang="en-US"/>
-              <a:t>9/2/2025</a:t>
+              <a:t>9/3/2026</a:t>
             </a:fld>
             <a:endParaRPr lang="en-US"/>
           </a:p>
@@ -3012,14 +3014,14 @@
           <p:nvPr>
             <p:extLst>
               <p:ext uri="{D42A27DB-BD31-4B8C-83A1-F6EECF244321}">
-                <p14:modId xmlns:p14="http://schemas.microsoft.com/office/powerpoint/2010/main" val="406735425"/>
+                <p14:modId xmlns:p14="http://schemas.microsoft.com/office/powerpoint/2010/main" val="309383244"/>
               </p:ext>
             </p:extLst>
           </p:nvPr>
         </p:nvGraphicFramePr>
         <p:xfrm>
           <a:off x="3158934" y="1862010"/>
-          <a:ext cx="4914260" cy="2307908"/>
+          <a:ext cx="4914260" cy="2313623"/>
         </p:xfrm>
         <a:graphic>
           <a:graphicData uri="http://schemas.openxmlformats.org/drawingml/2006/table">
@@ -3042,17 +3044,10 @@
                     </a:ext>
                   </a:extLst>
                 </a:gridCol>
-                <a:gridCol w="161925">
+                <a:gridCol w="407035">
                   <a:extLst>
                     <a:ext uri="{9D8B030D-6E8A-4147-A177-3AD203B41FA5}">
                       <a16:colId xmlns:a16="http://schemas.microsoft.com/office/drawing/2014/main" val="20002"/>
-                    </a:ext>
-                  </a:extLst>
-                </a:gridCol>
-                <a:gridCol w="245110">
-                  <a:extLst>
-                    <a:ext uri="{9D8B030D-6E8A-4147-A177-3AD203B41FA5}">
-                      <a16:colId xmlns:a16="http://schemas.microsoft.com/office/drawing/2014/main" val="20003"/>
                     </a:ext>
                   </a:extLst>
                 </a:gridCol>
@@ -3070,21 +3065,14 @@
                     </a:ext>
                   </a:extLst>
                 </a:gridCol>
-                <a:gridCol w="795655">
+                <a:gridCol w="762828">
                   <a:extLst>
                     <a:ext uri="{9D8B030D-6E8A-4147-A177-3AD203B41FA5}">
                       <a16:colId xmlns:a16="http://schemas.microsoft.com/office/drawing/2014/main" val="20006"/>
                     </a:ext>
                   </a:extLst>
                 </a:gridCol>
-                <a:gridCol w="135889">
-                  <a:extLst>
-                    <a:ext uri="{9D8B030D-6E8A-4147-A177-3AD203B41FA5}">
-                      <a16:colId xmlns:a16="http://schemas.microsoft.com/office/drawing/2014/main" val="20007"/>
-                    </a:ext>
-                  </a:extLst>
-                </a:gridCol>
-                <a:gridCol w="173989">
+                <a:gridCol w="342705">
                   <a:extLst>
                     <a:ext uri="{9D8B030D-6E8A-4147-A177-3AD203B41FA5}">
                       <a16:colId xmlns:a16="http://schemas.microsoft.com/office/drawing/2014/main" val="20008"/>
@@ -3114,7 +3102,7 @@
                 </a:gridCol>
               </a:tblGrid>
               <a:tr h="309245">
-                <a:tc gridSpan="3">
+                <a:tc gridSpan="2">
                   <a:txBody>
                     <a:bodyPr/>
                     <a:lstStyle/>
@@ -3175,17 +3163,7 @@
                     <a:bodyPr/>
                     <a:lstStyle/>
                     <a:p>
-                      <a:endParaRPr/>
-                    </a:p>
-                  </a:txBody>
-                  <a:tcPr marL="0" marR="0" marT="0" marB="0"/>
-                </a:tc>
-                <a:tc hMerge="1">
-                  <a:txBody>
-                    <a:bodyPr/>
-                    <a:lstStyle/>
-                    <a:p>
-                      <a:endParaRPr/>
+                      <a:endParaRPr lang="en-US"/>
                     </a:p>
                   </a:txBody>
                   <a:tcPr marL="0" marR="0" marT="0" marB="0"/>
@@ -3203,7 +3181,7 @@
                           <a:spcPts val="60"/>
                         </a:spcBef>
                       </a:pPr>
-                      <a:endParaRPr sz="1000">
+                      <a:endParaRPr lang="en-US" sz="1000">
                         <a:latin typeface="Times New Roman"/>
                         <a:cs typeface="Times New Roman"/>
                       </a:endParaRPr>
@@ -3215,7 +3193,7 @@
                         </a:lnSpc>
                       </a:pPr>
                       <a:r>
-                        <a:rPr sz="1000" spc="-50" dirty="0">
+                        <a:rPr lang="en-US" sz="1000" spc="-50">
                           <a:solidFill>
                             <a:srgbClr val="000080"/>
                           </a:solidFill>
@@ -3224,10 +3202,7 @@
                         </a:rPr>
                         <a:t>2</a:t>
                       </a:r>
-                      <a:endParaRPr sz="1000">
-                        <a:latin typeface="Arial"/>
-                        <a:cs typeface="Arial"/>
-                      </a:endParaRPr>
+                      <a:endParaRPr lang="en-US"/>
                     </a:p>
                   </a:txBody>
                   <a:tcPr marL="0" marR="0" marT="7620" marB="0">
@@ -3312,15 +3287,18 @@
                       </a:solidFill>
                       <a:prstDash val="solid"/>
                     </a:lnR>
-                    <a:lnB w="19050">
+                    <a:lnB w="19050" cap="flat" cmpd="sng" algn="ctr">
                       <a:solidFill>
                         <a:srgbClr val="000080"/>
                       </a:solidFill>
                       <a:prstDash val="solid"/>
+                      <a:round/>
+                      <a:headEnd type="none" w="med" len="med"/>
+                      <a:tailEnd type="none" w="med" len="med"/>
                     </a:lnB>
                   </a:tcPr>
                 </a:tc>
-                <a:tc gridSpan="3">
+                <a:tc gridSpan="2">
                   <a:txBody>
                     <a:bodyPr/>
                     <a:lstStyle/>
@@ -3363,7 +3341,7 @@
                         </a:rPr>
                         <a:t>Game</a:t>
                       </a:r>
-                      <a:endParaRPr sz="1000">
+                      <a:endParaRPr sz="1000" dirty="0">
                         <a:latin typeface="Arial"/>
                         <a:cs typeface="Arial"/>
                       </a:endParaRPr>
@@ -3395,16 +3373,6 @@
                       <a:prstDash val="solid"/>
                     </a:lnB>
                   </a:tcPr>
-                </a:tc>
-                <a:tc hMerge="1">
-                  <a:txBody>
-                    <a:bodyPr/>
-                    <a:lstStyle/>
-                    <a:p>
-                      <a:endParaRPr/>
-                    </a:p>
-                  </a:txBody>
-                  <a:tcPr marL="0" marR="0" marT="0" marB="0"/>
                 </a:tc>
                 <a:tc hMerge="1">
                   <a:txBody>
@@ -3477,23 +3445,32 @@
                     </a:p>
                   </a:txBody>
                   <a:tcPr marL="0" marR="0" marT="8890" marB="0">
-                    <a:lnL w="19050">
+                    <a:lnL w="19050" cap="flat" cmpd="sng" algn="ctr">
                       <a:solidFill>
                         <a:srgbClr val="000080"/>
                       </a:solidFill>
                       <a:prstDash val="solid"/>
+                      <a:round/>
+                      <a:headEnd type="none" w="med" len="med"/>
+                      <a:tailEnd type="none" w="med" len="med"/>
                     </a:lnL>
-                    <a:lnR w="19050">
+                    <a:lnR w="12700" cap="flat" cmpd="sng" algn="ctr">
+                      <a:solidFill>
+                        <a:schemeClr val="tx1"/>
+                      </a:solidFill>
+                      <a:prstDash val="solid"/>
+                      <a:round/>
+                      <a:headEnd type="none" w="med" len="med"/>
+                      <a:tailEnd type="none" w="med" len="med"/>
+                    </a:lnR>
+                    <a:lnB w="19050" cap="flat" cmpd="sng" algn="ctr">
                       <a:solidFill>
                         <a:srgbClr val="000080"/>
                       </a:solidFill>
                       <a:prstDash val="solid"/>
-                    </a:lnR>
-                    <a:lnB w="19050">
-                      <a:solidFill>
-                        <a:srgbClr val="000080"/>
-                      </a:solidFill>
-                      <a:prstDash val="solid"/>
+                      <a:round/>
+                      <a:headEnd type="none" w="med" len="med"/>
+                      <a:tailEnd type="none" w="med" len="med"/>
                     </a:lnB>
                   </a:tcPr>
                 </a:tc>
@@ -3530,36 +3507,48 @@
                         </a:rPr>
                         <a:t>Board</a:t>
                       </a:r>
-                      <a:endParaRPr sz="1000">
+                      <a:endParaRPr sz="1000" dirty="0">
                         <a:latin typeface="Arial"/>
                         <a:cs typeface="Arial"/>
                       </a:endParaRPr>
                     </a:p>
                   </a:txBody>
                   <a:tcPr marL="0" marR="0" marT="10160" marB="0">
-                    <a:lnL w="19050">
+                    <a:lnL w="12700" cap="flat" cmpd="sng" algn="ctr">
                       <a:solidFill>
-                        <a:srgbClr val="000080"/>
+                        <a:schemeClr val="tx1"/>
                       </a:solidFill>
                       <a:prstDash val="solid"/>
+                      <a:round/>
+                      <a:headEnd type="none" w="med" len="med"/>
+                      <a:tailEnd type="none" w="med" len="med"/>
                     </a:lnL>
-                    <a:lnR w="19050">
+                    <a:lnR w="12700" cap="flat" cmpd="sng" algn="ctr">
                       <a:solidFill>
-                        <a:srgbClr val="000080"/>
+                        <a:schemeClr val="tx1"/>
                       </a:solidFill>
                       <a:prstDash val="solid"/>
+                      <a:round/>
+                      <a:headEnd type="none" w="med" len="med"/>
+                      <a:tailEnd type="none" w="med" len="med"/>
                     </a:lnR>
-                    <a:lnT w="19050">
+                    <a:lnT w="12700" cap="flat" cmpd="sng" algn="ctr">
                       <a:solidFill>
-                        <a:srgbClr val="000080"/>
+                        <a:schemeClr val="tx1"/>
                       </a:solidFill>
                       <a:prstDash val="solid"/>
+                      <a:round/>
+                      <a:headEnd type="none" w="med" len="med"/>
+                      <a:tailEnd type="none" w="med" len="med"/>
                     </a:lnT>
-                    <a:lnB w="19050">
+                    <a:lnB w="12700" cap="flat" cmpd="sng" algn="ctr">
                       <a:solidFill>
-                        <a:srgbClr val="000080"/>
+                        <a:schemeClr val="tx1"/>
                       </a:solidFill>
                       <a:prstDash val="solid"/>
+                      <a:round/>
+                      <a:headEnd type="none" w="med" len="med"/>
+                      <a:tailEnd type="none" w="med" len="med"/>
                     </a:lnB>
                   </a:tcPr>
                 </a:tc>
@@ -3580,7 +3569,7 @@
                 </a:extLst>
               </a:tr>
               <a:tr h="310515">
-                <a:tc gridSpan="3">
+                <a:tc gridSpan="2">
                   <a:txBody>
                     <a:bodyPr/>
                     <a:lstStyle/>
@@ -3603,7 +3592,7 @@
                         </a:rPr>
                         <a:t>Count</a:t>
                       </a:r>
-                      <a:endParaRPr sz="1000">
+                      <a:endParaRPr sz="1000" dirty="0">
                         <a:latin typeface="Arial"/>
                         <a:cs typeface="Arial"/>
                       </a:endParaRPr>
@@ -3641,17 +3630,7 @@
                     <a:bodyPr/>
                     <a:lstStyle/>
                     <a:p>
-                      <a:endParaRPr/>
-                    </a:p>
-                  </a:txBody>
-                  <a:tcPr marL="0" marR="0" marT="0" marB="0"/>
-                </a:tc>
-                <a:tc hMerge="1">
-                  <a:txBody>
-                    <a:bodyPr/>
-                    <a:lstStyle/>
-                    <a:p>
-                      <a:endParaRPr/>
+                      <a:endParaRPr lang="en-US" dirty="0"/>
                     </a:p>
                   </a:txBody>
                   <a:tcPr marL="0" marR="0" marT="0" marB="0"/>
@@ -3661,15 +3640,7 @@
                     <a:bodyPr/>
                     <a:lstStyle/>
                     <a:p>
-                      <a:pPr>
-                        <a:lnSpc>
-                          <a:spcPct val="100000"/>
-                        </a:lnSpc>
-                      </a:pPr>
-                      <a:endParaRPr sz="1400">
-                        <a:latin typeface="Times New Roman"/>
-                        <a:cs typeface="Times New Roman"/>
-                      </a:endParaRPr>
+                      <a:endParaRPr lang="en-US" dirty="0"/>
                     </a:p>
                   </a:txBody>
                   <a:tcPr marL="0" marR="0" marT="0" marB="0">
@@ -3701,9 +3672,28 @@
                       <a:endParaRPr/>
                     </a:p>
                   </a:txBody>
-                  <a:tcPr marL="0" marR="0" marT="0" marB="0"/>
+                  <a:tcPr marL="0" marR="0" marT="0" marB="0">
+                    <a:lnL w="19050" cap="flat" cmpd="sng" algn="ctr">
+                      <a:solidFill>
+                        <a:srgbClr val="000080"/>
+                      </a:solidFill>
+                      <a:prstDash val="solid"/>
+                      <a:round/>
+                      <a:headEnd type="none" w="med" len="med"/>
+                      <a:tailEnd type="none" w="med" len="med"/>
+                    </a:lnL>
+                    <a:lnT w="19050" cap="flat" cmpd="sng" algn="ctr">
+                      <a:solidFill>
+                        <a:srgbClr val="000080"/>
+                      </a:solidFill>
+                      <a:prstDash val="solid"/>
+                      <a:round/>
+                      <a:headEnd type="none" w="med" len="med"/>
+                      <a:tailEnd type="none" w="med" len="med"/>
+                    </a:lnT>
+                  </a:tcPr>
                 </a:tc>
-                <a:tc gridSpan="3">
+                <a:tc gridSpan="2">
                   <a:txBody>
                     <a:bodyPr/>
                     <a:lstStyle/>
@@ -3713,10 +3703,7 @@
                           <a:spcPct val="100000"/>
                         </a:lnSpc>
                       </a:pPr>
-                      <a:endParaRPr sz="1400">
-                        <a:latin typeface="Times New Roman"/>
-                        <a:cs typeface="Times New Roman"/>
-                      </a:endParaRPr>
+                      <a:endParaRPr dirty="0"/>
                     </a:p>
                   </a:txBody>
                   <a:tcPr marL="0" marR="0" marT="0" marB="0">
@@ -3756,16 +3743,6 @@
                   </a:txBody>
                   <a:tcPr marL="0" marR="0" marT="0" marB="0"/>
                 </a:tc>
-                <a:tc hMerge="1">
-                  <a:txBody>
-                    <a:bodyPr/>
-                    <a:lstStyle/>
-                    <a:p>
-                      <a:endParaRPr/>
-                    </a:p>
-                  </a:txBody>
-                  <a:tcPr marL="0" marR="0" marT="0" marB="0"/>
-                </a:tc>
                 <a:tc gridSpan="2">
                   <a:txBody>
                     <a:bodyPr/>
@@ -3783,23 +3760,32 @@
                     </a:p>
                   </a:txBody>
                   <a:tcPr marL="0" marR="0" marT="0" marB="0">
-                    <a:lnL w="19050">
+                    <a:lnL w="19050" cap="flat" cmpd="sng" algn="ctr">
                       <a:solidFill>
                         <a:srgbClr val="000080"/>
                       </a:solidFill>
                       <a:prstDash val="solid"/>
+                      <a:round/>
+                      <a:headEnd type="none" w="med" len="med"/>
+                      <a:tailEnd type="none" w="med" len="med"/>
                     </a:lnL>
-                    <a:lnR w="19050">
+                    <a:lnR w="12700" cap="flat" cmpd="sng" algn="ctr">
+                      <a:solidFill>
+                        <a:schemeClr val="tx1"/>
+                      </a:solidFill>
+                      <a:prstDash val="solid"/>
+                      <a:round/>
+                      <a:headEnd type="none" w="med" len="med"/>
+                      <a:tailEnd type="none" w="med" len="med"/>
+                    </a:lnR>
+                    <a:lnT w="19050" cap="flat" cmpd="sng" algn="ctr">
                       <a:solidFill>
                         <a:srgbClr val="000080"/>
                       </a:solidFill>
                       <a:prstDash val="solid"/>
-                    </a:lnR>
-                    <a:lnT w="19050">
-                      <a:solidFill>
-                        <a:srgbClr val="000080"/>
-                      </a:solidFill>
-                      <a:prstDash val="solid"/>
+                      <a:round/>
+                      <a:headEnd type="none" w="med" len="med"/>
+                      <a:tailEnd type="none" w="med" len="med"/>
                     </a:lnT>
                   </a:tcPr>
                 </a:tc>
@@ -3823,36 +3809,48 @@
                           <a:spcPct val="100000"/>
                         </a:lnSpc>
                       </a:pPr>
-                      <a:endParaRPr sz="1400">
+                      <a:endParaRPr sz="1400" dirty="0">
                         <a:latin typeface="Times New Roman"/>
                         <a:cs typeface="Times New Roman"/>
                       </a:endParaRPr>
                     </a:p>
                   </a:txBody>
                   <a:tcPr marL="0" marR="0" marT="0" marB="0">
-                    <a:lnL w="19050">
+                    <a:lnL w="12700" cap="flat" cmpd="sng" algn="ctr">
                       <a:solidFill>
-                        <a:srgbClr val="000080"/>
+                        <a:schemeClr val="tx1"/>
                       </a:solidFill>
                       <a:prstDash val="solid"/>
+                      <a:round/>
+                      <a:headEnd type="none" w="med" len="med"/>
+                      <a:tailEnd type="none" w="med" len="med"/>
                     </a:lnL>
-                    <a:lnR w="19050">
+                    <a:lnR w="12700" cap="flat" cmpd="sng" algn="ctr">
                       <a:solidFill>
-                        <a:srgbClr val="000080"/>
+                        <a:schemeClr val="tx1"/>
                       </a:solidFill>
                       <a:prstDash val="solid"/>
+                      <a:round/>
+                      <a:headEnd type="none" w="med" len="med"/>
+                      <a:tailEnd type="none" w="med" len="med"/>
                     </a:lnR>
-                    <a:lnT w="19050">
+                    <a:lnT w="12700" cap="flat" cmpd="sng" algn="ctr">
                       <a:solidFill>
-                        <a:srgbClr val="000080"/>
+                        <a:schemeClr val="tx1"/>
                       </a:solidFill>
                       <a:prstDash val="solid"/>
+                      <a:round/>
+                      <a:headEnd type="none" w="med" len="med"/>
+                      <a:tailEnd type="none" w="med" len="med"/>
                     </a:lnT>
-                    <a:lnB w="19050">
+                    <a:lnB w="12700" cap="flat" cmpd="sng" algn="ctr">
                       <a:solidFill>
-                        <a:srgbClr val="000080"/>
+                        <a:schemeClr val="tx1"/>
                       </a:solidFill>
                       <a:prstDash val="solid"/>
+                      <a:round/>
+                      <a:headEnd type="none" w="med" len="med"/>
+                      <a:tailEnd type="none" w="med" len="med"/>
                     </a:lnB>
                   </a:tcPr>
                 </a:tc>
@@ -3872,7 +3870,7 @@
                   </a:ext>
                 </a:extLst>
               </a:tr>
-              <a:tr h="946660">
+              <a:tr h="979172">
                 <a:tc>
                   <a:txBody>
                     <a:bodyPr/>
@@ -4004,7 +4002,7 @@
                     </a:lnB>
                   </a:tcPr>
                 </a:tc>
-                <a:tc gridSpan="2">
+                <a:tc>
                   <a:txBody>
                     <a:bodyPr/>
                     <a:lstStyle/>
@@ -4090,16 +4088,6 @@
                   </a:txBody>
                   <a:tcPr marL="0" marR="0" marT="0" marB="0"/>
                 </a:tc>
-                <a:tc hMerge="1">
-                  <a:txBody>
-                    <a:bodyPr/>
-                    <a:lstStyle/>
-                    <a:p>
-                      <a:endParaRPr/>
-                    </a:p>
-                  </a:txBody>
-                  <a:tcPr marL="0" marR="0" marT="0" marB="0"/>
-                </a:tc>
                 <a:tc>
                   <a:txBody>
                     <a:bodyPr/>
@@ -4174,30 +4162,12 @@
                     </a:lnB>
                   </a:tcPr>
                 </a:tc>
-                <a:tc gridSpan="2">
+                <a:tc>
                   <a:txBody>
                     <a:bodyPr/>
                     <a:lstStyle/>
                     <a:p>
-                      <a:pPr>
-                        <a:lnSpc>
-                          <a:spcPct val="100000"/>
-                        </a:lnSpc>
-                      </a:pPr>
-                      <a:endParaRPr sz="1400" dirty="0">
-                        <a:latin typeface="Times New Roman"/>
-                        <a:cs typeface="Times New Roman"/>
-                      </a:endParaRPr>
-                    </a:p>
-                  </a:txBody>
-                  <a:tcPr marL="0" marR="0" marT="0" marB="0"/>
-                </a:tc>
-                <a:tc hMerge="1">
-                  <a:txBody>
-                    <a:bodyPr/>
-                    <a:lstStyle/>
-                    <a:p>
-                      <a:endParaRPr/>
+                      <a:endParaRPr lang="en-US"/>
                     </a:p>
                   </a:txBody>
                   <a:tcPr marL="0" marR="0" marT="0" marB="0"/>
@@ -4243,17 +4213,23 @@
                       </a:solidFill>
                       <a:prstDash val="solid"/>
                     </a:lnR>
-                    <a:lnT w="19050">
+                    <a:lnT w="12700" cap="flat" cmpd="sng" algn="ctr">
                       <a:solidFill>
-                        <a:srgbClr val="000080"/>
+                        <a:schemeClr val="tx1"/>
                       </a:solidFill>
                       <a:prstDash val="solid"/>
+                      <a:round/>
+                      <a:headEnd type="none" w="med" len="med"/>
+                      <a:tailEnd type="none" w="med" len="med"/>
                     </a:lnT>
-                    <a:lnB w="19050">
+                    <a:lnB w="12700" cap="flat" cmpd="sng" algn="ctr">
                       <a:solidFill>
-                        <a:srgbClr val="000080"/>
+                        <a:schemeClr val="tx1"/>
                       </a:solidFill>
                       <a:prstDash val="solid"/>
+                      <a:round/>
+                      <a:headEnd type="none" w="med" len="med"/>
+                      <a:tailEnd type="none" w="med" len="med"/>
                     </a:lnB>
                   </a:tcPr>
                 </a:tc>
@@ -4369,17 +4345,23 @@
                       </a:solidFill>
                       <a:prstDash val="solid"/>
                     </a:lnL>
-                    <a:lnT w="19050">
+                    <a:lnT w="12700" cap="flat" cmpd="sng" algn="ctr">
                       <a:solidFill>
-                        <a:srgbClr val="000080"/>
+                        <a:schemeClr val="tx1"/>
                       </a:solidFill>
                       <a:prstDash val="solid"/>
+                      <a:round/>
+                      <a:headEnd type="none" w="med" len="med"/>
+                      <a:tailEnd type="none" w="med" len="med"/>
                     </a:lnT>
-                    <a:lnB w="19050">
+                    <a:lnB w="12700" cap="flat" cmpd="sng" algn="ctr">
                       <a:solidFill>
-                        <a:srgbClr val="000080"/>
+                        <a:schemeClr val="tx1"/>
                       </a:solidFill>
                       <a:prstDash val="solid"/>
+                      <a:round/>
+                      <a:headEnd type="none" w="med" len="med"/>
+                      <a:tailEnd type="none" w="med" len="med"/>
                     </a:lnB>
                   </a:tcPr>
                 </a:tc>
@@ -4390,7 +4372,7 @@
                 </a:extLst>
               </a:tr>
               <a:tr h="310515">
-                <a:tc gridSpan="3">
+                <a:tc gridSpan="2">
                   <a:txBody>
                     <a:bodyPr/>
                     <a:lstStyle/>
@@ -4456,16 +4438,6 @@
                   </a:txBody>
                   <a:tcPr marL="0" marR="0" marT="0" marB="0"/>
                 </a:tc>
-                <a:tc hMerge="1">
-                  <a:txBody>
-                    <a:bodyPr/>
-                    <a:lstStyle/>
-                    <a:p>
-                      <a:endParaRPr/>
-                    </a:p>
-                  </a:txBody>
-                  <a:tcPr marL="0" marR="0" marT="0" marB="0"/>
-                </a:tc>
                 <a:tc gridSpan="3">
                   <a:txBody>
                     <a:bodyPr/>
@@ -4479,7 +4451,7 @@
                           <a:spcPts val="70"/>
                         </a:spcBef>
                       </a:pPr>
-                      <a:endParaRPr sz="1000">
+                      <a:endParaRPr lang="en-US" sz="1000" dirty="0">
                         <a:latin typeface="Times New Roman"/>
                         <a:cs typeface="Times New Roman"/>
                       </a:endParaRPr>
@@ -4491,7 +4463,7 @@
                         </a:lnSpc>
                       </a:pPr>
                       <a:r>
-                        <a:rPr sz="1000" spc="-10" dirty="0">
+                        <a:rPr lang="en-US" sz="1000" spc="-10" dirty="0">
                           <a:solidFill>
                             <a:srgbClr val="000080"/>
                           </a:solidFill>
@@ -4500,10 +4472,7 @@
                         </a:rPr>
                         <a:t>represents</a:t>
                       </a:r>
-                      <a:endParaRPr sz="1000">
-                        <a:latin typeface="Arial"/>
-                        <a:cs typeface="Arial"/>
-                      </a:endParaRPr>
+                      <a:endParaRPr lang="en-US" dirty="0"/>
                     </a:p>
                   </a:txBody>
                   <a:tcPr marL="0" marR="0" marT="8890" marB="0">
@@ -4535,7 +4504,17 @@
                       <a:endParaRPr/>
                     </a:p>
                   </a:txBody>
-                  <a:tcPr marL="0" marR="0" marT="0" marB="0"/>
+                  <a:tcPr marL="0" marR="0" marT="0" marB="0">
+                    <a:lnL w="19050" cap="flat" cmpd="sng" algn="ctr">
+                      <a:solidFill>
+                        <a:srgbClr val="000080"/>
+                      </a:solidFill>
+                      <a:prstDash val="solid"/>
+                      <a:round/>
+                      <a:headEnd type="none" w="med" len="med"/>
+                      <a:tailEnd type="none" w="med" len="med"/>
+                    </a:lnL>
+                  </a:tcPr>
                 </a:tc>
                 <a:tc hMerge="1">
                   <a:txBody>
@@ -4570,7 +4549,7 @@
                         </a:rPr>
                         <a:t>Piece</a:t>
                       </a:r>
-                      <a:endParaRPr sz="1000">
+                      <a:endParaRPr sz="1000" dirty="0">
                         <a:latin typeface="Arial"/>
                         <a:cs typeface="Arial"/>
                       </a:endParaRPr>
@@ -4603,7 +4582,7 @@
                     </a:lnB>
                   </a:tcPr>
                 </a:tc>
-                <a:tc gridSpan="2">
+                <a:tc>
                   <a:txBody>
                     <a:bodyPr/>
                     <a:lstStyle/>
@@ -4616,7 +4595,7 @@
                           <a:spcPts val="185"/>
                         </a:spcBef>
                       </a:pPr>
-                      <a:endParaRPr sz="1000">
+                      <a:endParaRPr lang="en-US" sz="1000">
                         <a:latin typeface="Times New Roman"/>
                         <a:cs typeface="Times New Roman"/>
                       </a:endParaRPr>
@@ -4628,7 +4607,7 @@
                         </a:lnSpc>
                       </a:pPr>
                       <a:r>
-                        <a:rPr sz="1000" spc="-20" dirty="0">
+                        <a:rPr lang="en-US" sz="1000" spc="-20">
                           <a:solidFill>
                             <a:srgbClr val="000080"/>
                           </a:solidFill>
@@ -4637,36 +4616,29 @@
                         </a:rPr>
                         <a:t>0..8</a:t>
                       </a:r>
-                      <a:endParaRPr sz="1000">
-                        <a:latin typeface="Arial"/>
-                        <a:cs typeface="Arial"/>
-                      </a:endParaRPr>
+                      <a:endParaRPr lang="en-US" dirty="0"/>
                     </a:p>
                   </a:txBody>
                   <a:tcPr marL="0" marR="0" marT="23495" marB="0">
-                    <a:lnL w="19050">
+                    <a:lnL w="19050" cap="flat" cmpd="sng" algn="ctr">
                       <a:solidFill>
                         <a:srgbClr val="000080"/>
                       </a:solidFill>
                       <a:prstDash val="solid"/>
+                      <a:round/>
+                      <a:headEnd type="none" w="med" len="med"/>
+                      <a:tailEnd type="none" w="med" len="med"/>
                     </a:lnL>
-                    <a:lnB w="19050">
+                    <a:lnB w="19050" cap="flat" cmpd="sng" algn="ctr">
                       <a:solidFill>
                         <a:srgbClr val="000080"/>
                       </a:solidFill>
                       <a:prstDash val="solid"/>
+                      <a:round/>
+                      <a:headEnd type="none" w="med" len="med"/>
+                      <a:tailEnd type="none" w="med" len="med"/>
                     </a:lnB>
                   </a:tcPr>
-                </a:tc>
-                <a:tc hMerge="1">
-                  <a:txBody>
-                    <a:bodyPr/>
-                    <a:lstStyle/>
-                    <a:p>
-                      <a:endParaRPr/>
-                    </a:p>
-                  </a:txBody>
-                  <a:tcPr marL="0" marR="0" marT="0" marB="0"/>
                 </a:tc>
                 <a:tc>
                   <a:txBody>
@@ -4726,11 +4698,14 @@
                     </a:p>
                   </a:txBody>
                   <a:tcPr marL="0" marR="0" marT="0" marB="0">
-                    <a:lnR w="19050">
+                    <a:lnR w="12700" cap="flat" cmpd="sng" algn="ctr">
                       <a:solidFill>
-                        <a:srgbClr val="000080"/>
+                        <a:schemeClr val="tx1"/>
                       </a:solidFill>
                       <a:prstDash val="solid"/>
+                      <a:round/>
+                      <a:headEnd type="none" w="med" len="med"/>
+                      <a:tailEnd type="none" w="med" len="med"/>
                     </a:lnR>
                     <a:lnB w="19050">
                       <a:solidFill>
@@ -4763,36 +4738,48 @@
                         </a:rPr>
                         <a:t>Square</a:t>
                       </a:r>
-                      <a:endParaRPr sz="1000">
+                      <a:endParaRPr sz="1000" dirty="0">
                         <a:latin typeface="Arial"/>
                         <a:cs typeface="Arial"/>
                       </a:endParaRPr>
                     </a:p>
                   </a:txBody>
                   <a:tcPr marL="0" marR="0" marT="11430" marB="0">
-                    <a:lnL w="19050">
+                    <a:lnL w="12700" cap="flat" cmpd="sng" algn="ctr">
                       <a:solidFill>
-                        <a:srgbClr val="000080"/>
+                        <a:schemeClr val="tx1"/>
                       </a:solidFill>
                       <a:prstDash val="solid"/>
+                      <a:round/>
+                      <a:headEnd type="none" w="med" len="med"/>
+                      <a:tailEnd type="none" w="med" len="med"/>
                     </a:lnL>
-                    <a:lnR w="19050">
+                    <a:lnR w="12700" cap="flat" cmpd="sng" algn="ctr">
                       <a:solidFill>
-                        <a:srgbClr val="000080"/>
+                        <a:schemeClr val="tx1"/>
                       </a:solidFill>
                       <a:prstDash val="solid"/>
+                      <a:round/>
+                      <a:headEnd type="none" w="med" len="med"/>
+                      <a:tailEnd type="none" w="med" len="med"/>
                     </a:lnR>
-                    <a:lnT w="19050">
+                    <a:lnT w="12700" cap="flat" cmpd="sng" algn="ctr">
                       <a:solidFill>
-                        <a:srgbClr val="000080"/>
+                        <a:schemeClr val="tx1"/>
                       </a:solidFill>
                       <a:prstDash val="solid"/>
+                      <a:round/>
+                      <a:headEnd type="none" w="med" len="med"/>
+                      <a:tailEnd type="none" w="med" len="med"/>
                     </a:lnT>
-                    <a:lnB w="19050">
+                    <a:lnB w="12700" cap="flat" cmpd="sng" algn="ctr">
                       <a:solidFill>
-                        <a:srgbClr val="000080"/>
+                        <a:schemeClr val="tx1"/>
                       </a:solidFill>
                       <a:prstDash val="solid"/>
+                      <a:round/>
+                      <a:headEnd type="none" w="med" len="med"/>
+                      <a:tailEnd type="none" w="med" len="med"/>
                     </a:lnB>
                   </a:tcPr>
                 </a:tc>
@@ -4813,7 +4800,7 @@
                 </a:extLst>
               </a:tr>
               <a:tr h="310515">
-                <a:tc gridSpan="3">
+                <a:tc gridSpan="2">
                   <a:txBody>
                     <a:bodyPr/>
                     <a:lstStyle/>
@@ -4866,30 +4853,12 @@
                   </a:txBody>
                   <a:tcPr marL="0" marR="0" marT="0" marB="0"/>
                 </a:tc>
-                <a:tc hMerge="1">
-                  <a:txBody>
-                    <a:bodyPr/>
-                    <a:lstStyle/>
-                    <a:p>
-                      <a:endParaRPr/>
-                    </a:p>
-                  </a:txBody>
-                  <a:tcPr marL="0" marR="0" marT="0" marB="0"/>
-                </a:tc>
                 <a:tc gridSpan="3">
                   <a:txBody>
                     <a:bodyPr/>
                     <a:lstStyle/>
                     <a:p>
-                      <a:pPr>
-                        <a:lnSpc>
-                          <a:spcPct val="100000"/>
-                        </a:lnSpc>
-                      </a:pPr>
-                      <a:endParaRPr sz="1400">
-                        <a:latin typeface="Times New Roman"/>
-                        <a:cs typeface="Times New Roman"/>
-                      </a:endParaRPr>
+                      <a:endParaRPr lang="en-US" dirty="0"/>
                     </a:p>
                   </a:txBody>
                   <a:tcPr marL="0" marR="0" marT="0" marB="0">
@@ -4921,7 +4890,17 @@
                       <a:endParaRPr/>
                     </a:p>
                   </a:txBody>
-                  <a:tcPr marL="0" marR="0" marT="0" marB="0"/>
+                  <a:tcPr marL="0" marR="0" marT="0" marB="0">
+                    <a:lnL w="19050" cap="flat" cmpd="sng" algn="ctr">
+                      <a:solidFill>
+                        <a:srgbClr val="000080"/>
+                      </a:solidFill>
+                      <a:prstDash val="solid"/>
+                      <a:round/>
+                      <a:headEnd type="none" w="med" len="med"/>
+                      <a:tailEnd type="none" w="med" len="med"/>
+                    </a:lnL>
+                  </a:tcPr>
                 </a:tc>
                 <a:tc hMerge="1">
                   <a:txBody>
@@ -4989,40 +4968,41 @@
                     </a:lnB>
                   </a:tcPr>
                 </a:tc>
-                <a:tc gridSpan="3">
+                <a:tc gridSpan="2">
                   <a:txBody>
                     <a:bodyPr/>
                     <a:lstStyle/>
                     <a:p>
-                      <a:pPr>
-                        <a:lnSpc>
-                          <a:spcPct val="100000"/>
-                        </a:lnSpc>
-                      </a:pPr>
-                      <a:endParaRPr sz="1400">
-                        <a:latin typeface="Times New Roman"/>
-                        <a:cs typeface="Times New Roman"/>
-                      </a:endParaRPr>
+                      <a:endParaRPr lang="en-US" dirty="0"/>
                     </a:p>
                   </a:txBody>
                   <a:tcPr marL="0" marR="0" marT="0" marB="0">
-                    <a:lnL w="19050">
+                    <a:lnL w="19050" cap="flat" cmpd="sng" algn="ctr">
                       <a:solidFill>
                         <a:srgbClr val="000080"/>
                       </a:solidFill>
                       <a:prstDash val="solid"/>
+                      <a:round/>
+                      <a:headEnd type="none" w="med" len="med"/>
+                      <a:tailEnd type="none" w="med" len="med"/>
                     </a:lnL>
-                    <a:lnR w="19050">
+                    <a:lnR w="12700" cap="flat" cmpd="sng" algn="ctr">
+                      <a:solidFill>
+                        <a:schemeClr val="tx1"/>
+                      </a:solidFill>
+                      <a:prstDash val="solid"/>
+                      <a:round/>
+                      <a:headEnd type="none" w="med" len="med"/>
+                      <a:tailEnd type="none" w="med" len="med"/>
+                    </a:lnR>
+                    <a:lnT w="19050" cap="flat" cmpd="sng" algn="ctr">
                       <a:solidFill>
                         <a:srgbClr val="000080"/>
                       </a:solidFill>
                       <a:prstDash val="solid"/>
-                    </a:lnR>
-                    <a:lnT w="19050">
-                      <a:solidFill>
-                        <a:srgbClr val="000080"/>
-                      </a:solidFill>
-                      <a:prstDash val="solid"/>
+                      <a:round/>
+                      <a:headEnd type="none" w="med" len="med"/>
+                      <a:tailEnd type="none" w="med" len="med"/>
                     </a:lnT>
                   </a:tcPr>
                 </a:tc>
@@ -5034,17 +5014,17 @@
                       <a:endParaRPr/>
                     </a:p>
                   </a:txBody>
-                  <a:tcPr marL="0" marR="0" marT="0" marB="0"/>
-                </a:tc>
-                <a:tc hMerge="1">
-                  <a:txBody>
-                    <a:bodyPr/>
-                    <a:lstStyle/>
-                    <a:p>
-                      <a:endParaRPr/>
-                    </a:p>
-                  </a:txBody>
-                  <a:tcPr marL="0" marR="0" marT="0" marB="0"/>
+                  <a:tcPr marL="0" marR="0" marT="0" marB="0">
+                    <a:lnT w="19050" cap="flat" cmpd="sng" algn="ctr">
+                      <a:solidFill>
+                        <a:srgbClr val="000080"/>
+                      </a:solidFill>
+                      <a:prstDash val="solid"/>
+                      <a:round/>
+                      <a:headEnd type="none" w="med" len="med"/>
+                      <a:tailEnd type="none" w="med" len="med"/>
+                    </a:lnT>
+                  </a:tcPr>
                 </a:tc>
                 <a:tc gridSpan="2">
                   <a:txBody>
@@ -5076,29 +5056,41 @@
                     </a:p>
                   </a:txBody>
                   <a:tcPr marL="0" marR="0" marT="66675" marB="0">
-                    <a:lnL w="19050">
+                    <a:lnL w="12700" cap="flat" cmpd="sng" algn="ctr">
                       <a:solidFill>
-                        <a:srgbClr val="000080"/>
+                        <a:schemeClr val="tx1"/>
                       </a:solidFill>
                       <a:prstDash val="solid"/>
+                      <a:round/>
+                      <a:headEnd type="none" w="med" len="med"/>
+                      <a:tailEnd type="none" w="med" len="med"/>
                     </a:lnL>
-                    <a:lnR w="19050">
+                    <a:lnR w="12700" cap="flat" cmpd="sng" algn="ctr">
                       <a:solidFill>
-                        <a:srgbClr val="000080"/>
+                        <a:schemeClr val="tx1"/>
                       </a:solidFill>
                       <a:prstDash val="solid"/>
+                      <a:round/>
+                      <a:headEnd type="none" w="med" len="med"/>
+                      <a:tailEnd type="none" w="med" len="med"/>
                     </a:lnR>
-                    <a:lnT w="19050">
+                    <a:lnT w="12700" cap="flat" cmpd="sng" algn="ctr">
                       <a:solidFill>
-                        <a:srgbClr val="000080"/>
+                        <a:schemeClr val="tx1"/>
                       </a:solidFill>
                       <a:prstDash val="solid"/>
+                      <a:round/>
+                      <a:headEnd type="none" w="med" len="med"/>
+                      <a:tailEnd type="none" w="med" len="med"/>
                     </a:lnT>
-                    <a:lnB w="19050">
+                    <a:lnB w="12700" cap="flat" cmpd="sng" algn="ctr">
                       <a:solidFill>
-                        <a:srgbClr val="000080"/>
+                        <a:schemeClr val="tx1"/>
                       </a:solidFill>
                       <a:prstDash val="solid"/>
+                      <a:round/>
+                      <a:headEnd type="none" w="med" len="med"/>
+                      <a:tailEnd type="none" w="med" len="med"/>
                     </a:lnB>
                   </a:tcPr>
                 </a:tc>
@@ -5177,7 +5169,13 @@
           <p:cNvGraphicFramePr>
             <a:graphicFrameLocks noGrp="1"/>
           </p:cNvGraphicFramePr>
-          <p:nvPr/>
+          <p:nvPr>
+            <p:extLst>
+              <p:ext uri="{D42A27DB-BD31-4B8C-83A1-F6EECF244321}">
+                <p14:modId xmlns:p14="http://schemas.microsoft.com/office/powerpoint/2010/main" val="1422601281"/>
+              </p:ext>
+            </p:extLst>
+          </p:nvPr>
         </p:nvGraphicFramePr>
         <p:xfrm>
           <a:off x="6249606" y="4353750"/>
@@ -5558,7 +5556,7 @@
                           <a:spcPct val="100000"/>
                         </a:lnSpc>
                       </a:pPr>
-                      <a:endParaRPr sz="1400">
+                      <a:endParaRPr sz="1400" dirty="0">
                         <a:latin typeface="Times New Roman"/>
                         <a:cs typeface="Times New Roman"/>
                       </a:endParaRPr>
@@ -5630,7 +5628,7 @@
                           <a:spcPct val="100000"/>
                         </a:lnSpc>
                       </a:pPr>
-                      <a:endParaRPr sz="1400">
+                      <a:endParaRPr sz="1400" dirty="0">
                         <a:latin typeface="Times New Roman"/>
                         <a:cs typeface="Times New Roman"/>
                       </a:endParaRPr>
@@ -5709,6 +5707,426 @@
           </p:nvPr>
         </p:nvSpPr>
         <p:spPr>
+          <a:xfrm>
+            <a:off x="206197" y="304800"/>
+            <a:ext cx="11779605" cy="509114"/>
+          </a:xfrm>
+          <a:prstGeom prst="rect">
+            <a:avLst/>
+          </a:prstGeom>
+        </p:spPr>
+        <p:txBody>
+          <a:bodyPr vert="horz" wrap="square" lIns="0" tIns="72390" rIns="0" bIns="0" rtlCol="0">
+            <a:spAutoFit/>
+          </a:bodyPr>
+          <a:lstStyle/>
+          <a:p>
+            <a:pPr marL="491490" marR="5080" algn="ctr">
+              <a:lnSpc>
+                <a:spcPts val="3420"/>
+              </a:lnSpc>
+              <a:spcBef>
+                <a:spcPts val="570"/>
+              </a:spcBef>
+            </a:pPr>
+            <a:r>
+              <a:rPr lang="en-US" dirty="0"/>
+              <a:t>Domain Model based on Project Description Domain Analysis</a:t>
+            </a:r>
+            <a:endParaRPr spc="-10" dirty="0"/>
+          </a:p>
+        </p:txBody>
+      </p:sp>
+      <p:pic>
+        <p:nvPicPr>
+          <p:cNvPr id="32" name="Picture 31" descr="A diagram of a restaurant&#10;&#10;Description automatically generated">
+            <a:extLst>
+              <a:ext uri="{FF2B5EF4-FFF2-40B4-BE49-F238E27FC236}">
+                <a16:creationId xmlns:a16="http://schemas.microsoft.com/office/drawing/2014/main" id="{78E4F56C-997C-6C53-9CFD-87A25B419FD1}"/>
+              </a:ext>
+            </a:extLst>
+          </p:cNvPr>
+          <p:cNvPicPr>
+            <a:picLocks noChangeAspect="1"/>
+          </p:cNvPicPr>
+          <p:nvPr/>
+        </p:nvPicPr>
+        <p:blipFill>
+          <a:blip r:embed="rId2">
+            <a:extLst>
+              <a:ext uri="{28A0092B-C50C-407E-A947-70E740481C1C}">
+                <a14:useLocalDpi xmlns:a14="http://schemas.microsoft.com/office/drawing/2010/main" val="0"/>
+              </a:ext>
+            </a:extLst>
+          </a:blip>
+          <a:stretch>
+            <a:fillRect/>
+          </a:stretch>
+        </p:blipFill>
+        <p:spPr>
+          <a:xfrm>
+            <a:off x="2895600" y="1143000"/>
+            <a:ext cx="5984456" cy="5291599"/>
+          </a:xfrm>
+          <a:prstGeom prst="rect">
+            <a:avLst/>
+          </a:prstGeom>
+        </p:spPr>
+      </p:pic>
+    </p:spTree>
+  </p:cSld>
+  <p:clrMapOvr>
+    <a:masterClrMapping/>
+  </p:clrMapOvr>
+</p:sld>
+</file>
+
+<file path=ppt/slides/slide11.xml><?xml version="1.0" encoding="utf-8"?>
+<p:sld xmlns:a="http://schemas.openxmlformats.org/drawingml/2006/main" xmlns:r="http://schemas.openxmlformats.org/officeDocument/2006/relationships" xmlns:p="http://schemas.openxmlformats.org/presentationml/2006/main">
+  <p:cSld>
+    <p:spTree>
+      <p:nvGrpSpPr>
+        <p:cNvPr id="1" name=""/>
+        <p:cNvGrpSpPr/>
+        <p:nvPr/>
+      </p:nvGrpSpPr>
+      <p:grpSpPr>
+        <a:xfrm>
+          <a:off x="0" y="0"/>
+          <a:ext cx="0" cy="0"/>
+          <a:chOff x="0" y="0"/>
+          <a:chExt cx="0" cy="0"/>
+        </a:xfrm>
+      </p:grpSpPr>
+      <p:sp>
+        <p:nvSpPr>
+          <p:cNvPr id="2" name="Title 1">
+            <a:extLst>
+              <a:ext uri="{FF2B5EF4-FFF2-40B4-BE49-F238E27FC236}">
+                <a16:creationId xmlns:a16="http://schemas.microsoft.com/office/drawing/2014/main" id="{362A0006-63D4-D52F-8F1F-B781C552D1C6}"/>
+              </a:ext>
+            </a:extLst>
+          </p:cNvPr>
+          <p:cNvSpPr>
+            <a:spLocks noGrp="1"/>
+          </p:cNvSpPr>
+          <p:nvPr>
+            <p:ph type="title"/>
+          </p:nvPr>
+        </p:nvSpPr>
+        <p:spPr>
+          <a:xfrm>
+            <a:off x="176276" y="28143"/>
+            <a:ext cx="11779605" cy="492443"/>
+          </a:xfrm>
+        </p:spPr>
+        <p:txBody>
+          <a:bodyPr/>
+          <a:lstStyle/>
+          <a:p>
+            <a:pPr algn="ctr"/>
+            <a:r>
+              <a:rPr lang="en-US" dirty="0"/>
+              <a:t>Discussion</a:t>
+            </a:r>
+          </a:p>
+        </p:txBody>
+      </p:sp>
+      <p:sp>
+        <p:nvSpPr>
+          <p:cNvPr id="4" name="Rectangle 1">
+            <a:extLst>
+              <a:ext uri="{FF2B5EF4-FFF2-40B4-BE49-F238E27FC236}">
+                <a16:creationId xmlns:a16="http://schemas.microsoft.com/office/drawing/2014/main" id="{31464FCE-3508-AEDF-B7FA-526619D75898}"/>
+              </a:ext>
+            </a:extLst>
+          </p:cNvPr>
+          <p:cNvSpPr>
+            <a:spLocks noGrp="1" noChangeArrowheads="1"/>
+          </p:cNvSpPr>
+          <p:nvPr>
+            <p:ph type="body" idx="1"/>
+          </p:nvPr>
+        </p:nvSpPr>
+        <p:spPr bwMode="auto">
+          <a:xfrm>
+            <a:off x="655638" y="2410958"/>
+            <a:ext cx="11338360" cy="2031325"/>
+          </a:xfrm>
+          <a:prstGeom prst="rect">
+            <a:avLst/>
+          </a:prstGeom>
+          <a:noFill/>
+          <a:ln>
+            <a:noFill/>
+          </a:ln>
+          <a:effectLst/>
+          <a:extLst>
+            <a:ext uri="{909E8E84-426E-40DD-AFC4-6F175D3DCCD1}">
+              <a14:hiddenFill xmlns:a14="http://schemas.microsoft.com/office/drawing/2010/main">
+                <a:solidFill>
+                  <a:schemeClr val="accent1"/>
+                </a:solidFill>
+              </a14:hiddenFill>
+            </a:ext>
+            <a:ext uri="{91240B29-F687-4F45-9708-019B960494DF}">
+              <a14:hiddenLine xmlns:a14="http://schemas.microsoft.com/office/drawing/2010/main" w="9525">
+                <a:solidFill>
+                  <a:schemeClr val="tx1"/>
+                </a:solidFill>
+                <a:miter lim="800000"/>
+                <a:headEnd/>
+                <a:tailEnd/>
+              </a14:hiddenLine>
+            </a:ext>
+            <a:ext uri="{AF507438-7753-43E0-B8FC-AC1667EBCBE1}">
+              <a14:hiddenEffects xmlns:a14="http://schemas.microsoft.com/office/drawing/2010/main">
+                <a:effectLst>
+                  <a:outerShdw dist="35921" dir="2700000" algn="ctr" rotWithShape="0">
+                    <a:schemeClr val="bg2"/>
+                  </a:outerShdw>
+                </a:effectLst>
+              </a14:hiddenEffects>
+            </a:ext>
+          </a:extLst>
+        </p:spPr>
+        <p:txBody>
+          <a:bodyPr vert="horz" wrap="none" lIns="91440" tIns="45720" rIns="91440" bIns="45720" numCol="1" anchor="ctr" anchorCtr="0" compatLnSpc="1">
+            <a:prstTxWarp prst="textNoShape">
+              <a:avLst/>
+            </a:prstTxWarp>
+            <a:spAutoFit/>
+          </a:bodyPr>
+          <a:lstStyle/>
+          <a:p>
+            <a:pPr marR="0" lvl="0" algn="l" defTabSz="914400" rtl="0" eaLnBrk="0" fontAlgn="base" latinLnBrk="0" hangingPunct="0">
+              <a:lnSpc>
+                <a:spcPct val="100000"/>
+              </a:lnSpc>
+              <a:spcBef>
+                <a:spcPct val="0"/>
+              </a:spcBef>
+              <a:spcAft>
+                <a:spcPct val="0"/>
+              </a:spcAft>
+              <a:buClrTx/>
+              <a:buSzTx/>
+              <a:tabLst/>
+            </a:pPr>
+            <a:r>
+              <a:rPr kumimoji="0" lang="en-US" altLang="en-US" sz="1800" b="0" i="0" u="none" strike="noStrike" cap="none" normalizeH="0" baseline="0" dirty="0">
+                <a:ln>
+                  <a:noFill/>
+                </a:ln>
+                <a:solidFill>
+                  <a:schemeClr val="tx1"/>
+                </a:solidFill>
+                <a:effectLst/>
+                <a:latin typeface="+mj-lt"/>
+              </a:rPr>
+              <a:t>1. What is the purpose of a Domain Model? How do you think it helps support software development?</a:t>
+            </a:r>
+          </a:p>
+          <a:p>
+            <a:pPr marL="0" marR="0" lvl="0" indent="0" algn="l" defTabSz="914400" rtl="0" eaLnBrk="0" fontAlgn="base" latinLnBrk="0" hangingPunct="0">
+              <a:lnSpc>
+                <a:spcPct val="100000"/>
+              </a:lnSpc>
+              <a:spcBef>
+                <a:spcPct val="0"/>
+              </a:spcBef>
+              <a:spcAft>
+                <a:spcPct val="0"/>
+              </a:spcAft>
+              <a:buClrTx/>
+              <a:buSzTx/>
+              <a:tabLst/>
+            </a:pPr>
+            <a:r>
+              <a:rPr kumimoji="0" lang="en-US" altLang="en-US" sz="1800" b="0" i="0" u="none" strike="noStrike" cap="none" normalizeH="0" baseline="0" dirty="0">
+                <a:ln>
+                  <a:noFill/>
+                </a:ln>
+                <a:solidFill>
+                  <a:schemeClr val="tx1"/>
+                </a:solidFill>
+                <a:effectLst/>
+                <a:latin typeface="+mj-lt"/>
+              </a:rPr>
+              <a:t>2. When might it hurt progress or add unnecessary overhead?</a:t>
+            </a:r>
+          </a:p>
+          <a:p>
+            <a:pPr lvl="0" algn="l" rtl="0" eaLnBrk="0" fontAlgn="base" hangingPunct="0">
+              <a:spcBef>
+                <a:spcPct val="0"/>
+              </a:spcBef>
+              <a:spcAft>
+                <a:spcPct val="0"/>
+              </a:spcAft>
+            </a:pPr>
+            <a:r>
+              <a:rPr lang="en-US" sz="1800" dirty="0">
+                <a:latin typeface="+mj-lt"/>
+              </a:rPr>
+              <a:t>3. How does a domain model help establish a </a:t>
+            </a:r>
+            <a:r>
+              <a:rPr lang="en-US" sz="1800" b="1" dirty="0">
+                <a:latin typeface="+mj-lt"/>
+              </a:rPr>
+              <a:t>shared vocabulary</a:t>
+            </a:r>
+            <a:r>
+              <a:rPr lang="en-US" sz="1800" dirty="0">
+                <a:latin typeface="+mj-lt"/>
+              </a:rPr>
+              <a:t> between developers, domain experts, and customers?</a:t>
+            </a:r>
+          </a:p>
+          <a:p>
+            <a:pPr lvl="0" algn="l" rtl="0" eaLnBrk="0" fontAlgn="base" hangingPunct="0">
+              <a:spcBef>
+                <a:spcPct val="0"/>
+              </a:spcBef>
+              <a:spcAft>
+                <a:spcPct val="0"/>
+              </a:spcAft>
+            </a:pPr>
+            <a:r>
+              <a:rPr lang="en-US" sz="1800" dirty="0">
+                <a:latin typeface="+mj-lt"/>
+              </a:rPr>
+              <a:t>4. What are examples of when a Domain Model is giving </a:t>
+            </a:r>
+            <a:r>
+              <a:rPr lang="en-US" sz="1800" b="1" dirty="0">
+                <a:latin typeface="+mj-lt"/>
+              </a:rPr>
+              <a:t>too much information</a:t>
+            </a:r>
+          </a:p>
+          <a:p>
+            <a:pPr lvl="0" algn="l" rtl="0" eaLnBrk="0" fontAlgn="base" hangingPunct="0">
+              <a:spcBef>
+                <a:spcPct val="0"/>
+              </a:spcBef>
+              <a:spcAft>
+                <a:spcPct val="0"/>
+              </a:spcAft>
+            </a:pPr>
+            <a:r>
+              <a:rPr lang="en-US" sz="1800" dirty="0">
+                <a:latin typeface="+mj-lt"/>
+              </a:rPr>
+              <a:t>5. Domain models evolve as requirements change—what risks arise if the domain model is </a:t>
+            </a:r>
+            <a:r>
+              <a:rPr lang="en-US" sz="1800" b="1" dirty="0">
+                <a:latin typeface="+mj-lt"/>
+              </a:rPr>
+              <a:t>not updated</a:t>
+            </a:r>
+            <a:r>
+              <a:rPr lang="en-US" sz="1800" dirty="0">
+                <a:latin typeface="+mj-lt"/>
+              </a:rPr>
+              <a:t>?</a:t>
+            </a:r>
+          </a:p>
+          <a:p>
+            <a:pPr lvl="0" algn="l" rtl="0" eaLnBrk="0" fontAlgn="base" hangingPunct="0">
+              <a:spcBef>
+                <a:spcPct val="0"/>
+              </a:spcBef>
+              <a:spcAft>
+                <a:spcPct val="0"/>
+              </a:spcAft>
+              <a:buFontTx/>
+              <a:buChar char="•"/>
+            </a:pPr>
+            <a:endParaRPr kumimoji="0" lang="en-US" altLang="en-US" sz="1800" b="0" i="0" u="none" strike="noStrike" cap="none" normalizeH="0" baseline="0" dirty="0">
+              <a:ln>
+                <a:noFill/>
+              </a:ln>
+              <a:solidFill>
+                <a:schemeClr val="tx1"/>
+              </a:solidFill>
+              <a:effectLst/>
+              <a:latin typeface="+mj-lt"/>
+            </a:endParaRPr>
+          </a:p>
+          <a:p>
+            <a:pPr marL="0" marR="0" lvl="0" indent="0" algn="l" defTabSz="914400" rtl="0" eaLnBrk="0" fontAlgn="base" latinLnBrk="0" hangingPunct="0">
+              <a:lnSpc>
+                <a:spcPct val="100000"/>
+              </a:lnSpc>
+              <a:spcBef>
+                <a:spcPct val="0"/>
+              </a:spcBef>
+              <a:spcAft>
+                <a:spcPct val="0"/>
+              </a:spcAft>
+              <a:buClrTx/>
+              <a:buSzTx/>
+              <a:buFontTx/>
+              <a:buChar char="•"/>
+              <a:tabLst/>
+            </a:pPr>
+            <a:endParaRPr kumimoji="0" lang="en-US" altLang="en-US" sz="1800" b="0" i="0" u="none" strike="noStrike" cap="none" normalizeH="0" baseline="0" dirty="0">
+              <a:ln>
+                <a:noFill/>
+              </a:ln>
+              <a:solidFill>
+                <a:schemeClr val="tx1"/>
+              </a:solidFill>
+              <a:effectLst/>
+              <a:latin typeface="+mj-lt"/>
+            </a:endParaRPr>
+          </a:p>
+        </p:txBody>
+      </p:sp>
+    </p:spTree>
+    <p:extLst>
+      <p:ext uri="{BB962C8B-B14F-4D97-AF65-F5344CB8AC3E}">
+        <p14:creationId xmlns:p14="http://schemas.microsoft.com/office/powerpoint/2010/main" val="3582059222"/>
+      </p:ext>
+    </p:extLst>
+  </p:cSld>
+  <p:clrMapOvr>
+    <a:masterClrMapping/>
+  </p:clrMapOvr>
+</p:sld>
+</file>
+
+<file path=ppt/slides/slide12.xml><?xml version="1.0" encoding="utf-8"?>
+<p:sld xmlns:a="http://schemas.openxmlformats.org/drawingml/2006/main" xmlns:r="http://schemas.openxmlformats.org/officeDocument/2006/relationships" xmlns:p="http://schemas.openxmlformats.org/presentationml/2006/main" showMasterSp="0">
+  <p:cSld>
+    <p:spTree>
+      <p:nvGrpSpPr>
+        <p:cNvPr id="1" name=""/>
+        <p:cNvGrpSpPr/>
+        <p:nvPr/>
+      </p:nvGrpSpPr>
+      <p:grpSpPr>
+        <a:xfrm>
+          <a:off x="0" y="0"/>
+          <a:ext cx="0" cy="0"/>
+          <a:chOff x="0" y="0"/>
+          <a:chExt cx="0" cy="0"/>
+        </a:xfrm>
+      </p:grpSpPr>
+      <p:sp>
+        <p:nvSpPr>
+          <p:cNvPr id="2" name="object 2"/>
+          <p:cNvSpPr txBox="1">
+            <a:spLocks noGrp="1"/>
+          </p:cNvSpPr>
+          <p:nvPr>
+            <p:ph type="title"/>
+          </p:nvPr>
+        </p:nvSpPr>
+        <p:spPr>
           <a:prstGeom prst="rect">
             <a:avLst/>
           </a:prstGeom>
@@ -12331,7 +12749,7 @@
               </a:rPr>
               <a:t>statement</a:t>
             </a:r>
-            <a:endParaRPr sz="2800">
+            <a:endParaRPr sz="2800" dirty="0">
               <a:latin typeface="Calibri"/>
               <a:cs typeface="Calibri"/>
             </a:endParaRPr>
@@ -12640,7 +13058,7 @@
               </a:rPr>
               <a:t>user</a:t>
             </a:r>
-            <a:endParaRPr sz="2400">
+            <a:endParaRPr sz="2400" dirty="0">
               <a:latin typeface="Calibri"/>
               <a:cs typeface="Calibri"/>
             </a:endParaRPr>
@@ -12781,7 +13199,7 @@
               </a:rPr>
               <a:t>model.</a:t>
             </a:r>
-            <a:endParaRPr sz="2400">
+            <a:endParaRPr sz="2400" dirty="0">
               <a:latin typeface="Calibri"/>
               <a:cs typeface="Calibri"/>
             </a:endParaRPr>
@@ -12954,7 +13372,7 @@
               </a:rPr>
               <a:t>team</a:t>
             </a:r>
-            <a:endParaRPr sz="2800">
+            <a:endParaRPr sz="2800" dirty="0">
               <a:latin typeface="Calibri"/>
               <a:cs typeface="Calibri"/>
             </a:endParaRPr>
@@ -16418,7 +16836,7 @@
           <p:nvPr>
             <p:extLst>
               <p:ext uri="{D42A27DB-BD31-4B8C-83A1-F6EECF244321}">
-                <p14:modId xmlns:p14="http://schemas.microsoft.com/office/powerpoint/2010/main" val="336771023"/>
+                <p14:modId xmlns:p14="http://schemas.microsoft.com/office/powerpoint/2010/main" val="3470470799"/>
               </p:ext>
             </p:extLst>
           </p:nvPr>
@@ -16577,14 +16995,14 @@
                         </a:spcBef>
                       </a:pPr>
                       <a:r>
-                        <a:rPr sz="1200" b="1" spc="-10" dirty="0">
+                        <a:rPr lang="en-US" sz="1200" b="1" spc="-10" dirty="0">
                           <a:solidFill>
                             <a:srgbClr val="000080"/>
                           </a:solidFill>
                           <a:latin typeface="Arial"/>
                           <a:cs typeface="Arial"/>
                         </a:rPr>
-                        <a:t>Address</a:t>
+                        <a:t>Distributor</a:t>
                       </a:r>
                       <a:endParaRPr sz="1200" dirty="0">
                         <a:latin typeface="Arial"/>
@@ -16773,8 +17191,8 @@
         </p:nvSpPr>
         <p:spPr>
           <a:xfrm>
-            <a:off x="4700268" y="5173390"/>
-            <a:ext cx="1524000" cy="276999"/>
+            <a:off x="4625108" y="5173389"/>
+            <a:ext cx="1008053" cy="276999"/>
           </a:xfrm>
           <a:prstGeom prst="rect">
             <a:avLst/>
@@ -16788,8 +17206,10 @@
           <a:lstStyle/>
           <a:p>
             <a:r>
-              <a:rPr lang="en-US" sz="1200" dirty="0"/>
-              <a:t>is shipping</a:t>
+              <a:rPr lang="en-US" sz="1200" dirty="0">
+                <a:latin typeface="+mn-lt"/>
+              </a:rPr>
+              <a:t>is shipping to</a:t>
             </a:r>
           </a:p>
         </p:txBody>
@@ -16808,8 +17228,8 @@
         </p:nvSpPr>
         <p:spPr>
           <a:xfrm>
-            <a:off x="5708321" y="5182448"/>
-            <a:ext cx="1295400" cy="276999"/>
+            <a:off x="5815544" y="5182447"/>
+            <a:ext cx="1133049" cy="276999"/>
           </a:xfrm>
           <a:prstGeom prst="rect">
             <a:avLst/>
@@ -16823,8 +17243,10 @@
           <a:lstStyle/>
           <a:p>
             <a:r>
-              <a:rPr lang="en-US" sz="1200" dirty="0"/>
-              <a:t>has location for</a:t>
+              <a:rPr lang="en-US" sz="1200" dirty="0">
+                <a:latin typeface="+mn-lt"/>
+              </a:rPr>
+              <a:t>has order with</a:t>
             </a:r>
           </a:p>
         </p:txBody>
@@ -16908,7 +17330,7 @@
 </file>
 
 <file path=ppt/slides/slide8.xml><?xml version="1.0" encoding="utf-8"?>
-<p:sld xmlns:a="http://schemas.openxmlformats.org/drawingml/2006/main" xmlns:r="http://schemas.openxmlformats.org/officeDocument/2006/relationships" xmlns:p="http://schemas.openxmlformats.org/presentationml/2006/main" showMasterSp="0">
+<p:sld xmlns:a="http://schemas.openxmlformats.org/drawingml/2006/main" xmlns:r="http://schemas.openxmlformats.org/officeDocument/2006/relationships" xmlns:p="http://schemas.openxmlformats.org/presentationml/2006/main">
   <p:cSld>
     <p:spTree>
       <p:nvGrpSpPr>
@@ -16926,8 +17348,14 @@
       </p:grpSpPr>
       <p:sp>
         <p:nvSpPr>
-          <p:cNvPr id="2" name="object 2"/>
-          <p:cNvSpPr txBox="1">
+          <p:cNvPr id="2" name="Title 1">
+            <a:extLst>
+              <a:ext uri="{FF2B5EF4-FFF2-40B4-BE49-F238E27FC236}">
+                <a16:creationId xmlns:a16="http://schemas.microsoft.com/office/drawing/2014/main" id="{CFADC208-51EA-8161-69D9-8045A0CC93ED}"/>
+              </a:ext>
+            </a:extLst>
+          </p:cNvPr>
+          <p:cNvSpPr>
             <a:spLocks noGrp="1"/>
           </p:cNvSpPr>
           <p:nvPr>
@@ -16936,124 +17364,139 @@
         </p:nvSpPr>
         <p:spPr>
           <a:xfrm>
-            <a:off x="176276" y="28143"/>
-            <a:ext cx="11779605" cy="509114"/>
+            <a:off x="206197" y="379159"/>
+            <a:ext cx="11779605" cy="492443"/>
           </a:xfrm>
-          <a:prstGeom prst="rect">
-            <a:avLst/>
-          </a:prstGeom>
         </p:spPr>
         <p:txBody>
-          <a:bodyPr vert="horz" wrap="square" lIns="0" tIns="72390" rIns="0" bIns="0" rtlCol="0">
-            <a:spAutoFit/>
-          </a:bodyPr>
+          <a:bodyPr/>
           <a:lstStyle/>
           <a:p>
-            <a:pPr marL="491490" marR="5080">
-              <a:lnSpc>
-                <a:spcPts val="3420"/>
-              </a:lnSpc>
-              <a:spcBef>
-                <a:spcPts val="570"/>
-              </a:spcBef>
-            </a:pPr>
-            <a:r>
-              <a:rPr dirty="0"/>
-              <a:t>This</a:t>
-            </a:r>
-            <a:r>
-              <a:rPr spc="-40" dirty="0"/>
-              <a:t> </a:t>
-            </a:r>
-            <a:r>
-              <a:rPr dirty="0"/>
-              <a:t>partial</a:t>
-            </a:r>
-            <a:r>
-              <a:rPr spc="-25" dirty="0"/>
-              <a:t> </a:t>
-            </a:r>
-            <a:r>
-              <a:rPr dirty="0"/>
-              <a:t>domain</a:t>
-            </a:r>
-            <a:r>
-              <a:rPr spc="-45" dirty="0"/>
-              <a:t> </a:t>
-            </a:r>
-            <a:r>
-              <a:rPr dirty="0"/>
-              <a:t>model</a:t>
-            </a:r>
-            <a:r>
-              <a:rPr spc="-25" dirty="0"/>
-              <a:t> </a:t>
-            </a:r>
-            <a:r>
-              <a:rPr dirty="0"/>
-              <a:t>for</a:t>
-            </a:r>
-            <a:r>
-              <a:rPr spc="-10" dirty="0"/>
-              <a:t> </a:t>
-            </a:r>
-            <a:r>
-              <a:rPr dirty="0"/>
-              <a:t>a</a:t>
-            </a:r>
-            <a:r>
-              <a:rPr spc="-15" dirty="0"/>
-              <a:t> </a:t>
-            </a:r>
-            <a:r>
-              <a:rPr lang="en-US" spc="-15" dirty="0"/>
-              <a:t>r</a:t>
-            </a:r>
+            <a:pPr algn="ctr"/>
             <a:r>
               <a:rPr lang="en-US" dirty="0"/>
-              <a:t>estaurant website</a:t>
-            </a:r>
-            <a:endParaRPr spc="-10" dirty="0"/>
+              <a:t>A Restaurant Reservation System Project Description</a:t>
+            </a:r>
           </a:p>
         </p:txBody>
       </p:sp>
-      <p:pic>
-        <p:nvPicPr>
-          <p:cNvPr id="32" name="Picture 31" descr="A diagram of a restaurant&#10;&#10;Description automatically generated">
+      <p:sp>
+        <p:nvSpPr>
+          <p:cNvPr id="3" name="Text Placeholder 2">
             <a:extLst>
               <a:ext uri="{FF2B5EF4-FFF2-40B4-BE49-F238E27FC236}">
-                <a16:creationId xmlns:a16="http://schemas.microsoft.com/office/drawing/2014/main" id="{78E4F56C-997C-6C53-9CFD-87A25B419FD1}"/>
+                <a16:creationId xmlns:a16="http://schemas.microsoft.com/office/drawing/2014/main" id="{79116397-1BB5-02A3-A981-4801121AE64B}"/>
               </a:ext>
             </a:extLst>
           </p:cNvPr>
-          <p:cNvPicPr>
-            <a:picLocks noChangeAspect="1"/>
-          </p:cNvPicPr>
-          <p:nvPr/>
-        </p:nvPicPr>
-        <p:blipFill>
-          <a:blip r:embed="rId2">
-            <a:extLst>
-              <a:ext uri="{28A0092B-C50C-407E-A947-70E740481C1C}">
-                <a14:useLocalDpi xmlns:a14="http://schemas.microsoft.com/office/drawing/2010/main" val="0"/>
-              </a:ext>
-            </a:extLst>
-          </a:blip>
-          <a:stretch>
-            <a:fillRect/>
-          </a:stretch>
-        </p:blipFill>
+          <p:cNvSpPr>
+            <a:spLocks noGrp="1"/>
+          </p:cNvSpPr>
+          <p:nvPr>
+            <p:ph type="body" idx="1"/>
+          </p:nvPr>
+        </p:nvSpPr>
         <p:spPr>
           <a:xfrm>
-            <a:off x="2895600" y="1143000"/>
-            <a:ext cx="5984456" cy="5291599"/>
+            <a:off x="655421" y="1061973"/>
+            <a:ext cx="11242675" cy="5170646"/>
           </a:xfrm>
-          <a:prstGeom prst="rect">
-            <a:avLst/>
-          </a:prstGeom>
         </p:spPr>
-      </p:pic>
+        <p:txBody>
+          <a:bodyPr/>
+          <a:lstStyle/>
+          <a:p>
+            <a:r>
+              <a:rPr lang="en-US" sz="2400" dirty="0"/>
+              <a:t>You are designing a restaurant reservation system. Each restaurant has</a:t>
+            </a:r>
+          </a:p>
+          <a:p>
+            <a:r>
+              <a:rPr lang="en-US" sz="2400" dirty="0"/>
+              <a:t>information about its location, type of food, hours of operation, and</a:t>
+            </a:r>
+          </a:p>
+          <a:p>
+            <a:r>
+              <a:rPr lang="en-US" sz="2400" dirty="0"/>
+              <a:t>reservations. The restaurants are broken up into regular, catering, and</a:t>
+            </a:r>
+          </a:p>
+          <a:p>
+            <a:r>
+              <a:rPr lang="en-US" sz="2400" dirty="0"/>
+              <a:t>take-out where making a reservation means a different thing for each</a:t>
+            </a:r>
+          </a:p>
+          <a:p>
+            <a:r>
+              <a:rPr lang="en-US" sz="2400" dirty="0"/>
+              <a:t>category of restaurant. Diners will be able to use the system either when</a:t>
+            </a:r>
+          </a:p>
+          <a:p>
+            <a:r>
+              <a:rPr lang="en-US" sz="2400" dirty="0"/>
+              <a:t>logged into their account or as a guest. Diners, either as guests or logged</a:t>
+            </a:r>
+          </a:p>
+          <a:p>
+            <a:r>
+              <a:rPr lang="en-US" sz="2400" dirty="0"/>
+              <a:t>in users, can make reservations. Reservations will be saved to a user's</a:t>
+            </a:r>
+          </a:p>
+          <a:p>
+            <a:r>
+              <a:rPr lang="en-US" sz="2400" dirty="0"/>
+              <a:t>account if they are logged in. Logged in users can also view, modify, or</a:t>
+            </a:r>
+          </a:p>
+          <a:p>
+            <a:r>
+              <a:rPr lang="en-US" sz="2400" dirty="0"/>
+              <a:t>delete reservations in their account. A user's account will store a name,</a:t>
+            </a:r>
+          </a:p>
+          <a:p>
+            <a:r>
+              <a:rPr lang="en-US" sz="2400" dirty="0"/>
+              <a:t>rewards points, and their upcoming and past reservations. Restaurant</a:t>
+            </a:r>
+          </a:p>
+          <a:p>
+            <a:r>
+              <a:rPr lang="en-US" sz="2400" dirty="0"/>
+              <a:t>users will have an account which can view, modify, or delete any</a:t>
+            </a:r>
+          </a:p>
+          <a:p>
+            <a:r>
+              <a:rPr lang="en-US" sz="2400" dirty="0"/>
+              <a:t>reservation made for their restaurant. The restaurant user can also</a:t>
+            </a:r>
+          </a:p>
+          <a:p>
+            <a:r>
+              <a:rPr lang="en-US" sz="2400" dirty="0"/>
+              <a:t>complete a reservation when diners arrive. All users will authenticate</a:t>
+            </a:r>
+          </a:p>
+          <a:p>
+            <a:r>
+              <a:rPr lang="en-US" sz="2400" dirty="0"/>
+              <a:t>using a password or Google login.</a:t>
+            </a:r>
+          </a:p>
+        </p:txBody>
+      </p:sp>
     </p:spTree>
+    <p:extLst>
+      <p:ext uri="{BB962C8B-B14F-4D97-AF65-F5344CB8AC3E}">
+        <p14:creationId xmlns:p14="http://schemas.microsoft.com/office/powerpoint/2010/main" val="4126272716"/>
+      </p:ext>
+    </p:extLst>
   </p:cSld>
   <p:clrMapOvr>
     <a:masterClrMapping/>
@@ -17083,7 +17526,7 @@
           <p:cNvPr id="2" name="Title 1">
             <a:extLst>
               <a:ext uri="{FF2B5EF4-FFF2-40B4-BE49-F238E27FC236}">
-                <a16:creationId xmlns:a16="http://schemas.microsoft.com/office/drawing/2014/main" id="{362A0006-63D4-D52F-8F1F-B781C552D1C6}"/>
+                <a16:creationId xmlns:a16="http://schemas.microsoft.com/office/drawing/2014/main" id="{EADBF77C-2274-E7AE-772E-6EE9212A0906}"/>
               </a:ext>
             </a:extLst>
           </p:cNvPr>
@@ -17096,7 +17539,7 @@
         </p:nvSpPr>
         <p:spPr>
           <a:xfrm>
-            <a:off x="176276" y="28143"/>
+            <a:off x="130688" y="457200"/>
             <a:ext cx="11779605" cy="492443"/>
           </a:xfrm>
         </p:spPr>
@@ -17107,269 +17550,45 @@
             <a:pPr algn="ctr"/>
             <a:r>
               <a:rPr lang="en-US" dirty="0"/>
-              <a:t>Discussion</a:t>
+              <a:t>Identifying Nouns and Verbs</a:t>
             </a:r>
           </a:p>
         </p:txBody>
       </p:sp>
-      <p:sp>
-        <p:nvSpPr>
-          <p:cNvPr id="4" name="Rectangle 1">
+      <p:pic>
+        <p:nvPicPr>
+          <p:cNvPr id="7" name="Picture 6">
             <a:extLst>
               <a:ext uri="{FF2B5EF4-FFF2-40B4-BE49-F238E27FC236}">
-                <a16:creationId xmlns:a16="http://schemas.microsoft.com/office/drawing/2014/main" id="{31464FCE-3508-AEDF-B7FA-526619D75898}"/>
+                <a16:creationId xmlns:a16="http://schemas.microsoft.com/office/drawing/2014/main" id="{33AA6C9B-B4FE-4243-DD00-59E39F64FE89}"/>
               </a:ext>
             </a:extLst>
           </p:cNvPr>
-          <p:cNvSpPr>
-            <a:spLocks noGrp="1" noChangeArrowheads="1"/>
-          </p:cNvSpPr>
-          <p:nvPr>
-            <p:ph type="body" idx="1"/>
-          </p:nvPr>
-        </p:nvSpPr>
-        <p:spPr bwMode="auto">
+          <p:cNvPicPr>
+            <a:picLocks noChangeAspect="1"/>
+          </p:cNvPicPr>
+          <p:nvPr/>
+        </p:nvPicPr>
+        <p:blipFill>
+          <a:blip r:embed="rId2"/>
+          <a:stretch>
+            <a:fillRect/>
+          </a:stretch>
+        </p:blipFill>
+        <p:spPr>
           <a:xfrm>
-            <a:off x="655638" y="2410958"/>
-            <a:ext cx="11338360" cy="2031325"/>
+            <a:off x="1066800" y="1371600"/>
+            <a:ext cx="9907383" cy="4982270"/>
           </a:xfrm>
           <a:prstGeom prst="rect">
             <a:avLst/>
           </a:prstGeom>
-          <a:noFill/>
-          <a:ln>
-            <a:noFill/>
-          </a:ln>
-          <a:effectLst/>
-          <a:extLst>
-            <a:ext uri="{909E8E84-426E-40DD-AFC4-6F175D3DCCD1}">
-              <a14:hiddenFill xmlns:a14="http://schemas.microsoft.com/office/drawing/2010/main">
-                <a:solidFill>
-                  <a:schemeClr val="accent1"/>
-                </a:solidFill>
-              </a14:hiddenFill>
-            </a:ext>
-            <a:ext uri="{91240B29-F687-4F45-9708-019B960494DF}">
-              <a14:hiddenLine xmlns:a14="http://schemas.microsoft.com/office/drawing/2010/main" w="9525">
-                <a:solidFill>
-                  <a:schemeClr val="tx1"/>
-                </a:solidFill>
-                <a:miter lim="800000"/>
-                <a:headEnd/>
-                <a:tailEnd/>
-              </a14:hiddenLine>
-            </a:ext>
-            <a:ext uri="{AF507438-7753-43E0-B8FC-AC1667EBCBE1}">
-              <a14:hiddenEffects xmlns:a14="http://schemas.microsoft.com/office/drawing/2010/main">
-                <a:effectLst>
-                  <a:outerShdw dist="35921" dir="2700000" algn="ctr" rotWithShape="0">
-                    <a:schemeClr val="bg2"/>
-                  </a:outerShdw>
-                </a:effectLst>
-              </a14:hiddenEffects>
-            </a:ext>
-          </a:extLst>
         </p:spPr>
-        <p:txBody>
-          <a:bodyPr vert="horz" wrap="none" lIns="91440" tIns="45720" rIns="91440" bIns="45720" numCol="1" anchor="ctr" anchorCtr="0" compatLnSpc="1">
-            <a:prstTxWarp prst="textNoShape">
-              <a:avLst/>
-            </a:prstTxWarp>
-            <a:spAutoFit/>
-          </a:bodyPr>
-          <a:lstStyle/>
-          <a:p>
-            <a:pPr marR="0" lvl="0" algn="l" defTabSz="914400" rtl="0" eaLnBrk="0" fontAlgn="base" latinLnBrk="0" hangingPunct="0">
-              <a:lnSpc>
-                <a:spcPct val="100000"/>
-              </a:lnSpc>
-              <a:spcBef>
-                <a:spcPct val="0"/>
-              </a:spcBef>
-              <a:spcAft>
-                <a:spcPct val="0"/>
-              </a:spcAft>
-              <a:buClrTx/>
-              <a:buSzTx/>
-              <a:tabLst/>
-            </a:pPr>
-            <a:r>
-              <a:rPr kumimoji="0" lang="en-US" altLang="en-US" sz="1800" b="0" i="0" u="none" strike="noStrike" cap="none" normalizeH="0" baseline="0" dirty="0">
-                <a:ln>
-                  <a:noFill/>
-                </a:ln>
-                <a:solidFill>
-                  <a:schemeClr val="tx1"/>
-                </a:solidFill>
-                <a:effectLst/>
-                <a:latin typeface="+mj-lt"/>
-              </a:rPr>
-              <a:t>1. What is the purpose of a Domain Model? How do you think it helps support software development?</a:t>
-            </a:r>
-          </a:p>
-          <a:p>
-            <a:pPr marL="0" marR="0" lvl="0" indent="0" algn="l" defTabSz="914400" rtl="0" eaLnBrk="0" fontAlgn="base" latinLnBrk="0" hangingPunct="0">
-              <a:lnSpc>
-                <a:spcPct val="100000"/>
-              </a:lnSpc>
-              <a:spcBef>
-                <a:spcPct val="0"/>
-              </a:spcBef>
-              <a:spcAft>
-                <a:spcPct val="0"/>
-              </a:spcAft>
-              <a:buClrTx/>
-              <a:buSzTx/>
-              <a:tabLst/>
-            </a:pPr>
-            <a:r>
-              <a:rPr kumimoji="0" lang="en-US" altLang="en-US" sz="1800" b="0" i="0" u="none" strike="noStrike" cap="none" normalizeH="0" baseline="0" dirty="0">
-                <a:ln>
-                  <a:noFill/>
-                </a:ln>
-                <a:solidFill>
-                  <a:schemeClr val="tx1"/>
-                </a:solidFill>
-                <a:effectLst/>
-                <a:latin typeface="+mj-lt"/>
-              </a:rPr>
-              <a:t>2. When might it hurt progress or add unnecessary overhead?</a:t>
-            </a:r>
-          </a:p>
-          <a:p>
-            <a:pPr lvl="0" algn="l" rtl="0" eaLnBrk="0" fontAlgn="base" hangingPunct="0">
-              <a:spcBef>
-                <a:spcPct val="0"/>
-              </a:spcBef>
-              <a:spcAft>
-                <a:spcPct val="0"/>
-              </a:spcAft>
-            </a:pPr>
-            <a:r>
-              <a:rPr lang="en-US" sz="1800" dirty="0">
-                <a:latin typeface="+mj-lt"/>
-              </a:rPr>
-              <a:t>3. How does a domain model help establish a </a:t>
-            </a:r>
-            <a:r>
-              <a:rPr lang="en-US" sz="1800" b="1" dirty="0">
-                <a:latin typeface="+mj-lt"/>
-              </a:rPr>
-              <a:t>shared vocabulary</a:t>
-            </a:r>
-            <a:r>
-              <a:rPr lang="en-US" sz="1800" dirty="0">
-                <a:latin typeface="+mj-lt"/>
-              </a:rPr>
-              <a:t> between developers, domain experts, and customers?</a:t>
-            </a:r>
-          </a:p>
-          <a:p>
-            <a:pPr lvl="0" algn="l" rtl="0" eaLnBrk="0" fontAlgn="base" hangingPunct="0">
-              <a:spcBef>
-                <a:spcPct val="0"/>
-              </a:spcBef>
-              <a:spcAft>
-                <a:spcPct val="0"/>
-              </a:spcAft>
-            </a:pPr>
-            <a:r>
-              <a:rPr lang="en-US" sz="1800" dirty="0">
-                <a:latin typeface="+mj-lt"/>
-              </a:rPr>
-              <a:t>4. What are examples of when a Domain Model is giving </a:t>
-            </a:r>
-            <a:r>
-              <a:rPr lang="en-US" sz="1800" b="1" dirty="0">
-                <a:latin typeface="+mj-lt"/>
-              </a:rPr>
-              <a:t>too much information</a:t>
-            </a:r>
-          </a:p>
-          <a:p>
-            <a:pPr lvl="0" algn="l" rtl="0" eaLnBrk="0" fontAlgn="base" hangingPunct="0">
-              <a:spcBef>
-                <a:spcPct val="0"/>
-              </a:spcBef>
-              <a:spcAft>
-                <a:spcPct val="0"/>
-              </a:spcAft>
-            </a:pPr>
-            <a:r>
-              <a:rPr lang="en-US" sz="1800" dirty="0">
-                <a:latin typeface="+mj-lt"/>
-              </a:rPr>
-              <a:t>5. Domain models evolve as requirements change—what risks arise if the domain model is </a:t>
-            </a:r>
-            <a:r>
-              <a:rPr lang="en-US" sz="1800" b="1" dirty="0">
-                <a:latin typeface="+mj-lt"/>
-              </a:rPr>
-              <a:t>not updated</a:t>
-            </a:r>
-            <a:r>
-              <a:rPr lang="en-US" sz="1800" dirty="0">
-                <a:latin typeface="+mj-lt"/>
-              </a:rPr>
-              <a:t>?</a:t>
-            </a:r>
-          </a:p>
-          <a:p>
-            <a:pPr lvl="0" algn="l" rtl="0" eaLnBrk="0" fontAlgn="base" hangingPunct="0">
-              <a:spcBef>
-                <a:spcPct val="0"/>
-              </a:spcBef>
-              <a:spcAft>
-                <a:spcPct val="0"/>
-              </a:spcAft>
-              <a:buFontTx/>
-              <a:buChar char="•"/>
-            </a:pPr>
-            <a:endParaRPr kumimoji="0" lang="en-US" altLang="en-US" sz="1800" b="0" i="0" u="none" strike="noStrike" cap="none" normalizeH="0" baseline="0" dirty="0">
-              <a:ln>
-                <a:noFill/>
-              </a:ln>
-              <a:solidFill>
-                <a:schemeClr val="tx1"/>
-              </a:solidFill>
-              <a:effectLst/>
-              <a:latin typeface="+mj-lt"/>
-            </a:endParaRPr>
-          </a:p>
-          <a:p>
-            <a:pPr marL="0" marR="0" lvl="0" indent="0" algn="l" defTabSz="914400" rtl="0" eaLnBrk="0" fontAlgn="base" latinLnBrk="0" hangingPunct="0">
-              <a:lnSpc>
-                <a:spcPct val="100000"/>
-              </a:lnSpc>
-              <a:spcBef>
-                <a:spcPct val="0"/>
-              </a:spcBef>
-              <a:spcAft>
-                <a:spcPct val="0"/>
-              </a:spcAft>
-              <a:buClrTx/>
-              <a:buSzTx/>
-              <a:buFontTx/>
-              <a:buChar char="•"/>
-              <a:tabLst/>
-            </a:pPr>
-            <a:endParaRPr kumimoji="0" lang="en-US" altLang="en-US" sz="1800" b="0" i="0" u="none" strike="noStrike" cap="none" normalizeH="0" baseline="0" dirty="0">
-              <a:ln>
-                <a:noFill/>
-              </a:ln>
-              <a:solidFill>
-                <a:schemeClr val="tx1"/>
-              </a:solidFill>
-              <a:effectLst/>
-              <a:latin typeface="+mj-lt"/>
-            </a:endParaRPr>
-          </a:p>
-        </p:txBody>
-      </p:sp>
+      </p:pic>
     </p:spTree>
     <p:extLst>
       <p:ext uri="{BB962C8B-B14F-4D97-AF65-F5344CB8AC3E}">
-        <p14:creationId xmlns:p14="http://schemas.microsoft.com/office/powerpoint/2010/main" val="3582059222"/>
+        <p14:creationId xmlns:p14="http://schemas.microsoft.com/office/powerpoint/2010/main" val="3799829928"/>
       </p:ext>
     </p:extLst>
   </p:cSld>

</xml_diff>